<commit_message>
Architecture deck in English (architecture-integration.pptx/pdf); builder generates IT and EN
Developed by Roberto Navoni : r.navoni74@gmail.com
</commit_message>
<xml_diff>
--- a/docs/architettura-integrazione.pptx
+++ b/docs/architettura-integrazione.pptx
@@ -4201,7 +4201,7 @@
             </a:pPr>
             <a:r>
               <a:rPr sz="1200" b="0"/>
-              <a:t>•  mode manual · rc all 1500 · arm throttle → 8 s in piedi</a:t>
+              <a:t>•  mode manual · rc all 1500 · arm throttle → 6 s in piedi</a:t>
             </a:r>
           </a:p>
           <a:p>
@@ -4212,7 +4212,7 @@
             </a:pPr>
             <a:r>
               <a:rPr sz="1200" b="0"/>
-              <a:t>•  rc 2 2000 → avanti 12 s (≈2.6 m)</a:t>
+              <a:t>•  rc 2 2000 → avanti 3 s · rc 2 1000 → indietro 2 s</a:t>
             </a:r>
           </a:p>
           <a:p>
@@ -4223,7 +4223,7 @@
             </a:pPr>
             <a:r>
               <a:rPr sz="1200" b="0"/>
-              <a:t>•  rc 1 1800 → laterale 8 s · rc 4 2000 → rotazione 8 s</a:t>
+              <a:t>•  rc 1 1800 → laterale 2 s · rc 4 2000 → rotazione 90° (integrale di ATTITUDE.yawspeed) · rc 2 2000 → avanti 5 s</a:t>
             </a:r>
           </a:p>
           <a:p>
@@ -4260,7 +4260,7 @@
             </a:pPr>
             <a:r>
               <a:rPr sz="1200" b="0"/>
-              <a:t>•  pannello a sinistra: comando MAVProxy e messaggio MAVLink corrispondente</a:t>
+              <a:t>•  box crediti e pannello a sinistra: comando MAVProxy e messaggio MAVLink corrispondente</a:t>
             </a:r>
           </a:p>
           <a:p>

</xml_diff>